<commit_message>
Slides terzas versione. WIP
</commit_message>
<xml_diff>
--- a/06_relazioni_e_parametri/Slides_v2/04_metodo-vqe.pptx
+++ b/06_relazioni_e_parametri/Slides_v2/04_metodo-vqe.pptx
@@ -2479,366 +2479,6 @@
                       </p:childTnLst>
                     </p:cTn>
                   </p:par>
-                  <p:par>
-                    <p:cTn id="11" fill="hold">
-                      <p:stCondLst>
-                        <p:cond delay="indefinite"/>
-                      </p:stCondLst>
-                      <p:childTnLst>
-                        <p:par>
-                          <p:cTn id="12" fill="hold">
-                            <p:stCondLst>
-                              <p:cond delay="0"/>
-                            </p:stCondLst>
-                            <p:childTnLst>
-                              <p:par>
-                                <p:cTn id="13" presetID="42" presetClass="entr" presetSubtype="0" fill="hold" grpId="0" nodeType="clickEffect">
-                                  <p:stCondLst>
-                                    <p:cond delay="0"/>
-                                  </p:stCondLst>
-                                  <p:childTnLst>
-                                    <p:set>
-                                      <p:cBhvr>
-                                        <p:cTn id="14" dur="1" fill="hold">
-                                          <p:stCondLst>
-                                            <p:cond delay="0"/>
-                                          </p:stCondLst>
-                                        </p:cTn>
-                                        <p:tgtEl>
-                                          <p:spTgt spid="22"/>
-                                        </p:tgtEl>
-                                        <p:attrNameLst>
-                                          <p:attrName>style.visibility</p:attrName>
-                                        </p:attrNameLst>
-                                      </p:cBhvr>
-                                      <p:to>
-                                        <p:strVal val="visible"/>
-                                      </p:to>
-                                    </p:set>
-                                    <p:animEffect transition="in" filter="fade">
-                                      <p:cBhvr>
-                                        <p:cTn id="15" dur="1000"/>
-                                        <p:tgtEl>
-                                          <p:spTgt spid="22"/>
-                                        </p:tgtEl>
-                                      </p:cBhvr>
-                                    </p:animEffect>
-                                    <p:anim calcmode="lin" valueType="num">
-                                      <p:cBhvr>
-                                        <p:cTn id="16" dur="1000" fill="hold"/>
-                                        <p:tgtEl>
-                                          <p:spTgt spid="22"/>
-                                        </p:tgtEl>
-                                        <p:attrNameLst>
-                                          <p:attrName>ppt_x</p:attrName>
-                                        </p:attrNameLst>
-                                      </p:cBhvr>
-                                      <p:tavLst>
-                                        <p:tav tm="0">
-                                          <p:val>
-                                            <p:strVal val="#ppt_x"/>
-                                          </p:val>
-                                        </p:tav>
-                                        <p:tav tm="100000">
-                                          <p:val>
-                                            <p:strVal val="#ppt_x"/>
-                                          </p:val>
-                                        </p:tav>
-                                      </p:tavLst>
-                                    </p:anim>
-                                    <p:anim calcmode="lin" valueType="num">
-                                      <p:cBhvr>
-                                        <p:cTn id="17" dur="1000" fill="hold"/>
-                                        <p:tgtEl>
-                                          <p:spTgt spid="22"/>
-                                        </p:tgtEl>
-                                        <p:attrNameLst>
-                                          <p:attrName>ppt_y</p:attrName>
-                                        </p:attrNameLst>
-                                      </p:cBhvr>
-                                      <p:tavLst>
-                                        <p:tav tm="0">
-                                          <p:val>
-                                            <p:strVal val="#ppt_y+.1"/>
-                                          </p:val>
-                                        </p:tav>
-                                        <p:tav tm="100000">
-                                          <p:val>
-                                            <p:strVal val="#ppt_y"/>
-                                          </p:val>
-                                        </p:tav>
-                                      </p:tavLst>
-                                    </p:anim>
-                                  </p:childTnLst>
-                                </p:cTn>
-                              </p:par>
-                              <p:par>
-                                <p:cTn id="18" presetID="42" presetClass="entr" presetSubtype="0" fill="hold" grpId="0" nodeType="withEffect">
-                                  <p:stCondLst>
-                                    <p:cond delay="0"/>
-                                  </p:stCondLst>
-                                  <p:childTnLst>
-                                    <p:set>
-                                      <p:cBhvr>
-                                        <p:cTn id="19" dur="1" fill="hold">
-                                          <p:stCondLst>
-                                            <p:cond delay="0"/>
-                                          </p:stCondLst>
-                                        </p:cTn>
-                                        <p:tgtEl>
-                                          <p:spTgt spid="17"/>
-                                        </p:tgtEl>
-                                        <p:attrNameLst>
-                                          <p:attrName>style.visibility</p:attrName>
-                                        </p:attrNameLst>
-                                      </p:cBhvr>
-                                      <p:to>
-                                        <p:strVal val="visible"/>
-                                      </p:to>
-                                    </p:set>
-                                    <p:animEffect transition="in" filter="fade">
-                                      <p:cBhvr>
-                                        <p:cTn id="20" dur="1000"/>
-                                        <p:tgtEl>
-                                          <p:spTgt spid="17"/>
-                                        </p:tgtEl>
-                                      </p:cBhvr>
-                                    </p:animEffect>
-                                    <p:anim calcmode="lin" valueType="num">
-                                      <p:cBhvr>
-                                        <p:cTn id="21" dur="1000" fill="hold"/>
-                                        <p:tgtEl>
-                                          <p:spTgt spid="17"/>
-                                        </p:tgtEl>
-                                        <p:attrNameLst>
-                                          <p:attrName>ppt_x</p:attrName>
-                                        </p:attrNameLst>
-                                      </p:cBhvr>
-                                      <p:tavLst>
-                                        <p:tav tm="0">
-                                          <p:val>
-                                            <p:strVal val="#ppt_x"/>
-                                          </p:val>
-                                        </p:tav>
-                                        <p:tav tm="100000">
-                                          <p:val>
-                                            <p:strVal val="#ppt_x"/>
-                                          </p:val>
-                                        </p:tav>
-                                      </p:tavLst>
-                                    </p:anim>
-                                    <p:anim calcmode="lin" valueType="num">
-                                      <p:cBhvr>
-                                        <p:cTn id="22" dur="1000" fill="hold"/>
-                                        <p:tgtEl>
-                                          <p:spTgt spid="17"/>
-                                        </p:tgtEl>
-                                        <p:attrNameLst>
-                                          <p:attrName>ppt_y</p:attrName>
-                                        </p:attrNameLst>
-                                      </p:cBhvr>
-                                      <p:tavLst>
-                                        <p:tav tm="0">
-                                          <p:val>
-                                            <p:strVal val="#ppt_y+.1"/>
-                                          </p:val>
-                                        </p:tav>
-                                        <p:tav tm="100000">
-                                          <p:val>
-                                            <p:strVal val="#ppt_y"/>
-                                          </p:val>
-                                        </p:tav>
-                                      </p:tavLst>
-                                    </p:anim>
-                                  </p:childTnLst>
-                                </p:cTn>
-                              </p:par>
-                            </p:childTnLst>
-                          </p:cTn>
-                        </p:par>
-                      </p:childTnLst>
-                    </p:cTn>
-                  </p:par>
-                  <p:par>
-                    <p:cTn id="23" fill="hold">
-                      <p:stCondLst>
-                        <p:cond delay="indefinite"/>
-                      </p:stCondLst>
-                      <p:childTnLst>
-                        <p:par>
-                          <p:cTn id="24" fill="hold">
-                            <p:stCondLst>
-                              <p:cond delay="0"/>
-                            </p:stCondLst>
-                            <p:childTnLst>
-                              <p:par>
-                                <p:cTn id="25" presetID="42" presetClass="entr" presetSubtype="0" fill="hold" grpId="0" nodeType="clickEffect">
-                                  <p:stCondLst>
-                                    <p:cond delay="0"/>
-                                  </p:stCondLst>
-                                  <p:childTnLst>
-                                    <p:set>
-                                      <p:cBhvr>
-                                        <p:cTn id="26" dur="1" fill="hold">
-                                          <p:stCondLst>
-                                            <p:cond delay="0"/>
-                                          </p:stCondLst>
-                                        </p:cTn>
-                                        <p:tgtEl>
-                                          <p:spTgt spid="23"/>
-                                        </p:tgtEl>
-                                        <p:attrNameLst>
-                                          <p:attrName>style.visibility</p:attrName>
-                                        </p:attrNameLst>
-                                      </p:cBhvr>
-                                      <p:to>
-                                        <p:strVal val="visible"/>
-                                      </p:to>
-                                    </p:set>
-                                    <p:animEffect transition="in" filter="fade">
-                                      <p:cBhvr>
-                                        <p:cTn id="27" dur="1000"/>
-                                        <p:tgtEl>
-                                          <p:spTgt spid="23"/>
-                                        </p:tgtEl>
-                                      </p:cBhvr>
-                                    </p:animEffect>
-                                    <p:anim calcmode="lin" valueType="num">
-                                      <p:cBhvr>
-                                        <p:cTn id="28" dur="1000" fill="hold"/>
-                                        <p:tgtEl>
-                                          <p:spTgt spid="23"/>
-                                        </p:tgtEl>
-                                        <p:attrNameLst>
-                                          <p:attrName>ppt_x</p:attrName>
-                                        </p:attrNameLst>
-                                      </p:cBhvr>
-                                      <p:tavLst>
-                                        <p:tav tm="0">
-                                          <p:val>
-                                            <p:strVal val="#ppt_x"/>
-                                          </p:val>
-                                        </p:tav>
-                                        <p:tav tm="100000">
-                                          <p:val>
-                                            <p:strVal val="#ppt_x"/>
-                                          </p:val>
-                                        </p:tav>
-                                      </p:tavLst>
-                                    </p:anim>
-                                    <p:anim calcmode="lin" valueType="num">
-                                      <p:cBhvr>
-                                        <p:cTn id="29" dur="1000" fill="hold"/>
-                                        <p:tgtEl>
-                                          <p:spTgt spid="23"/>
-                                        </p:tgtEl>
-                                        <p:attrNameLst>
-                                          <p:attrName>ppt_y</p:attrName>
-                                        </p:attrNameLst>
-                                      </p:cBhvr>
-                                      <p:tavLst>
-                                        <p:tav tm="0">
-                                          <p:val>
-                                            <p:strVal val="#ppt_y+.1"/>
-                                          </p:val>
-                                        </p:tav>
-                                        <p:tav tm="100000">
-                                          <p:val>
-                                            <p:strVal val="#ppt_y"/>
-                                          </p:val>
-                                        </p:tav>
-                                      </p:tavLst>
-                                    </p:anim>
-                                  </p:childTnLst>
-                                </p:cTn>
-                              </p:par>
-                              <p:par>
-                                <p:cTn id="30" presetID="42" presetClass="entr" presetSubtype="0" fill="hold" grpId="0" nodeType="withEffect">
-                                  <p:stCondLst>
-                                    <p:cond delay="0"/>
-                                  </p:stCondLst>
-                                  <p:childTnLst>
-                                    <p:set>
-                                      <p:cBhvr>
-                                        <p:cTn id="31" dur="1" fill="hold">
-                                          <p:stCondLst>
-                                            <p:cond delay="0"/>
-                                          </p:stCondLst>
-                                        </p:cTn>
-                                        <p:tgtEl>
-                                          <p:spTgt spid="24"/>
-                                        </p:tgtEl>
-                                        <p:attrNameLst>
-                                          <p:attrName>style.visibility</p:attrName>
-                                        </p:attrNameLst>
-                                      </p:cBhvr>
-                                      <p:to>
-                                        <p:strVal val="visible"/>
-                                      </p:to>
-                                    </p:set>
-                                    <p:animEffect transition="in" filter="fade">
-                                      <p:cBhvr>
-                                        <p:cTn id="32" dur="1000"/>
-                                        <p:tgtEl>
-                                          <p:spTgt spid="24"/>
-                                        </p:tgtEl>
-                                      </p:cBhvr>
-                                    </p:animEffect>
-                                    <p:anim calcmode="lin" valueType="num">
-                                      <p:cBhvr>
-                                        <p:cTn id="33" dur="1000" fill="hold"/>
-                                        <p:tgtEl>
-                                          <p:spTgt spid="24"/>
-                                        </p:tgtEl>
-                                        <p:attrNameLst>
-                                          <p:attrName>ppt_x</p:attrName>
-                                        </p:attrNameLst>
-                                      </p:cBhvr>
-                                      <p:tavLst>
-                                        <p:tav tm="0">
-                                          <p:val>
-                                            <p:strVal val="#ppt_x"/>
-                                          </p:val>
-                                        </p:tav>
-                                        <p:tav tm="100000">
-                                          <p:val>
-                                            <p:strVal val="#ppt_x"/>
-                                          </p:val>
-                                        </p:tav>
-                                      </p:tavLst>
-                                    </p:anim>
-                                    <p:anim calcmode="lin" valueType="num">
-                                      <p:cBhvr>
-                                        <p:cTn id="34" dur="1000" fill="hold"/>
-                                        <p:tgtEl>
-                                          <p:spTgt spid="24"/>
-                                        </p:tgtEl>
-                                        <p:attrNameLst>
-                                          <p:attrName>ppt_y</p:attrName>
-                                        </p:attrNameLst>
-                                      </p:cBhvr>
-                                      <p:tavLst>
-                                        <p:tav tm="0">
-                                          <p:val>
-                                            <p:strVal val="#ppt_y+.1"/>
-                                          </p:val>
-                                        </p:tav>
-                                        <p:tav tm="100000">
-                                          <p:val>
-                                            <p:strVal val="#ppt_y"/>
-                                          </p:val>
-                                        </p:tav>
-                                      </p:tavLst>
-                                    </p:anim>
-                                  </p:childTnLst>
-                                </p:cTn>
-                              </p:par>
-                            </p:childTnLst>
-                          </p:cTn>
-                        </p:par>
-                      </p:childTnLst>
-                    </p:cTn>
-                  </p:par>
                 </p:childTnLst>
               </p:cTn>
               <p:prevCondLst>
@@ -2862,10 +2502,6 @@
     </p:tnLst>
     <p:bldLst>
       <p:bldP spid="13" grpId="0" animBg="1"/>
-      <p:bldP spid="17" grpId="0"/>
-      <p:bldP spid="22" grpId="0" animBg="1"/>
-      <p:bldP spid="23" grpId="0" animBg="1"/>
-      <p:bldP spid="24" grpId="0"/>
     </p:bldLst>
   </p:timing>
 </p:sld>

</xml_diff>